<commit_message>
Update presentation file for practical implementation and AI-supported coding analysis
</commit_message>
<xml_diff>
--- a/5. Implementação Prática e Coding suportado por IA_Éder/Claude Code no VS Code do primeiro contato a uma análise reproduzível.pptx
+++ b/5. Implementação Prática e Coding suportado por IA_Éder/Claude Code no VS Code do primeiro contato a uma análise reproduzível.pptx
@@ -287,12 +287,20 @@
 </p:presentation>
 </file>
 
+<file path=ppt/revisionInfo.xml><?xml version="1.0" encoding="utf-8"?>
+<p1510:revInfo xmlns:a="http://schemas.openxmlformats.org/drawingml/2006/main" xmlns:r="http://schemas.openxmlformats.org/officeDocument/2006/relationships" xmlns:p1510="http://schemas.microsoft.com/office/powerpoint/2015/10/main">
+  <p1510:revLst>
+    <p1510:client id="{850B5965-5434-4939-A9C5-B32637F6BFAD}" v="2" dt="2026-10-26T12:10:27.528"/>
+  </p1510:revLst>
+</p1510:revInfo>
+</file>
+
 <file path=ppt/changesInfos/changesInfo1.xml><?xml version="1.0" encoding="utf-8"?>
 <pc:chgInfo xmlns:a="http://schemas.openxmlformats.org/drawingml/2006/main" xmlns:r="http://schemas.openxmlformats.org/officeDocument/2006/relationships" xmlns:ac="http://schemas.microsoft.com/office/drawing/2013/main/command" xmlns:pc="http://schemas.microsoft.com/office/powerpoint/2013/main/command">
   <pc:docChgLst>
     <pc:chgData name="Eder Silva" userId="9b7f41b4-798d-40cf-8f87-8e33ae7a0417" providerId="ADAL" clId="{DFF9E84E-5922-4F26-9EAD-8AB4E668133E}"/>
     <pc:docChg chg="mod modSld modMainMaster">
-      <pc:chgData name="Eder Silva" userId="9b7f41b4-798d-40cf-8f87-8e33ae7a0417" providerId="ADAL" clId="{DFF9E84E-5922-4F26-9EAD-8AB4E668133E}" dt="2026-10-20T13:32:56.704" v="2" actId="33475"/>
+      <pc:chgData name="Eder Silva" userId="9b7f41b4-798d-40cf-8f87-8e33ae7a0417" providerId="ADAL" clId="{DFF9E84E-5922-4F26-9EAD-8AB4E668133E}" dt="2026-10-26T12:10:30.209" v="8"/>
       <pc:docMkLst>
         <pc:docMk/>
       </pc:docMkLst>
@@ -308,6 +316,36 @@
             <pc:docMk/>
             <pc:sldMk cId="0" sldId="276"/>
             <ac:spMk id="4" creationId="{00000000-0000-0000-0000-000000000000}"/>
+          </ac:spMkLst>
+        </pc:spChg>
+      </pc:sldChg>
+      <pc:sldChg chg="addSp delSp modSp mod">
+        <pc:chgData name="Eder Silva" userId="9b7f41b4-798d-40cf-8f87-8e33ae7a0417" providerId="ADAL" clId="{DFF9E84E-5922-4F26-9EAD-8AB4E668133E}" dt="2026-10-26T12:09:55.321" v="5"/>
+        <pc:sldMkLst>
+          <pc:docMk/>
+          <pc:sldMk cId="0" sldId="287"/>
+        </pc:sldMkLst>
+        <pc:spChg chg="add del mod">
+          <ac:chgData name="Eder Silva" userId="9b7f41b4-798d-40cf-8f87-8e33ae7a0417" providerId="ADAL" clId="{DFF9E84E-5922-4F26-9EAD-8AB4E668133E}" dt="2026-10-26T12:09:55.321" v="5"/>
+          <ac:spMkLst>
+            <pc:docMk/>
+            <pc:sldMk cId="0" sldId="287"/>
+            <ac:spMk id="7" creationId="{C71DDE0C-EA32-094F-DEC9-91159ED22235}"/>
+          </ac:spMkLst>
+        </pc:spChg>
+      </pc:sldChg>
+      <pc:sldChg chg="addSp delSp modSp mod">
+        <pc:chgData name="Eder Silva" userId="9b7f41b4-798d-40cf-8f87-8e33ae7a0417" providerId="ADAL" clId="{DFF9E84E-5922-4F26-9EAD-8AB4E668133E}" dt="2026-10-26T12:10:30.209" v="8"/>
+        <pc:sldMkLst>
+          <pc:docMk/>
+          <pc:sldMk cId="0" sldId="299"/>
+        </pc:sldMkLst>
+        <pc:spChg chg="add del mod">
+          <ac:chgData name="Eder Silva" userId="9b7f41b4-798d-40cf-8f87-8e33ae7a0417" providerId="ADAL" clId="{DFF9E84E-5922-4F26-9EAD-8AB4E668133E}" dt="2026-10-26T12:10:30.209" v="8"/>
+          <ac:spMkLst>
+            <pc:docMk/>
+            <pc:sldMk cId="0" sldId="299"/>
+            <ac:spMk id="3" creationId="{1D222867-4BFB-74CA-2B87-6F4C251B3150}"/>
           </ac:spMkLst>
         </pc:spChg>
       </pc:sldChg>
@@ -6022,7 +6060,7 @@
           </a:prstGeom>
           <a:extLst>
             <a:ext uri="{C572A759-6A51-4108-AA02-DFA0A04FC94B}">
-              <ma14:wrappingTextBoxFlag xmlns:ma14="http://schemas.microsoft.com/office/mac/drawingml/2011/main" xmlns="" val="0"/>
+              <ma14:wrappingTextBoxFlag xmlns="" xmlns:ma14="http://schemas.microsoft.com/office/mac/drawingml/2011/main" val="0"/>
             </a:ext>
           </a:extLst>
         </p:spPr>
@@ -6144,7 +6182,7 @@
           </a:prstGeom>
           <a:extLst>
             <a:ext uri="{C572A759-6A51-4108-AA02-DFA0A04FC94B}">
-              <ma14:wrappingTextBoxFlag xmlns:ma14="http://schemas.microsoft.com/office/mac/drawingml/2011/main" xmlns="" val="0"/>
+              <ma14:wrappingTextBoxFlag xmlns="" xmlns:ma14="http://schemas.microsoft.com/office/mac/drawingml/2011/main" val="0"/>
             </a:ext>
           </a:extLst>
         </p:spPr>
@@ -6222,7 +6260,7 @@
           </a:prstGeom>
           <a:extLst>
             <a:ext uri="{C572A759-6A51-4108-AA02-DFA0A04FC94B}">
-              <ma14:wrappingTextBoxFlag xmlns:ma14="http://schemas.microsoft.com/office/mac/drawingml/2011/main" xmlns="" val="0"/>
+              <ma14:wrappingTextBoxFlag xmlns="" xmlns:ma14="http://schemas.microsoft.com/office/mac/drawingml/2011/main" val="0"/>
             </a:ext>
           </a:extLst>
         </p:spPr>
@@ -6247,54 +6285,6 @@
               <a:t>‹#›</a:t>
             </a:fld>
             <a:endParaRPr lang="en-US"/>
-          </a:p>
-        </p:txBody>
-      </p:sp>
-      <p:sp>
-        <p:nvSpPr>
-          <p:cNvPr id="3" name="TextBox 2">
-            <a:extLst>
-              <a:ext uri="{FF2B5EF4-FFF2-40B4-BE49-F238E27FC236}">
-                <a16:creationId xmlns:a16="http://schemas.microsoft.com/office/drawing/2014/main" id="{734FE698-F61F-6DCA-EA57-43B4DE6BE347}"/>
-              </a:ext>
-            </a:extLst>
-          </p:cNvPr>
-          <p:cNvSpPr txBox="1"/>
-          <p:nvPr userDrawn="1">
-            <p:extLst>
-              <p:ext uri="{1162E1C5-73C7-4A58-AE30-91384D911F3F}">
-                <p184:classification xmlns:p184="http://schemas.microsoft.com/office/powerpoint/2018/4/main" val="ftr"/>
-              </p:ext>
-            </p:extLst>
-          </p:nvPr>
-        </p:nvSpPr>
-        <p:spPr>
-          <a:xfrm>
-            <a:off x="10604500" y="6459220"/>
-            <a:ext cx="1581150" cy="335280"/>
-          </a:xfrm>
-          <a:prstGeom prst="rect">
-            <a:avLst/>
-          </a:prstGeom>
-        </p:spPr>
-        <p:txBody>
-          <a:bodyPr horzOverflow="overflow" lIns="0" tIns="0" rIns="0" bIns="0">
-            <a:spAutoFit/>
-          </a:bodyPr>
-          <a:lstStyle/>
-          <a:p>
-            <a:pPr algn="l"/>
-            <a:r>
-              <a:rPr lang="en-US" sz="2200">
-                <a:solidFill>
-                  <a:srgbClr val="FF8939">
-                    <a:alpha val="50000"/>
-                  </a:srgbClr>
-                </a:solidFill>
-                <a:latin typeface="Aptos" panose="020B0004020202020204" pitchFamily="34" charset="0"/>
-              </a:rPr>
-              <a:t>RESTRICTED</a:t>
-            </a:r>
           </a:p>
         </p:txBody>
       </p:sp>
@@ -9983,7 +9973,7 @@
           </a:prstGeom>
           <a:extLst>
             <a:ext uri="{C572A759-6A51-4108-AA02-DFA0A04FC94B}">
-              <ma14:wrappingTextBoxFlag xmlns:ma14="http://schemas.microsoft.com/office/mac/drawingml/2011/main" xmlns="" val="0"/>
+              <ma14:wrappingTextBoxFlag xmlns="" xmlns:ma14="http://schemas.microsoft.com/office/mac/drawingml/2011/main" val="0"/>
             </a:ext>
           </a:extLst>
         </p:spPr>
@@ -10549,7 +10539,7 @@
           </a:prstGeom>
           <a:extLst>
             <a:ext uri="{C572A759-6A51-4108-AA02-DFA0A04FC94B}">
-              <ma14:wrappingTextBoxFlag xmlns:ma14="http://schemas.microsoft.com/office/mac/drawingml/2011/main" xmlns="" val="0"/>
+              <ma14:wrappingTextBoxFlag xmlns="" xmlns:ma14="http://schemas.microsoft.com/office/mac/drawingml/2011/main" val="0"/>
             </a:ext>
           </a:extLst>
         </p:spPr>
@@ -11580,7 +11570,7 @@
           </a:prstGeom>
           <a:extLst>
             <a:ext uri="{C572A759-6A51-4108-AA02-DFA0A04FC94B}">
-              <ma14:wrappingTextBoxFlag xmlns:ma14="http://schemas.microsoft.com/office/mac/drawingml/2011/main" xmlns="" val="0"/>
+              <ma14:wrappingTextBoxFlag xmlns="" xmlns:ma14="http://schemas.microsoft.com/office/mac/drawingml/2011/main" val="0"/>
             </a:ext>
           </a:extLst>
         </p:spPr>
@@ -11816,7 +11806,7 @@
           </a:prstGeom>
           <a:extLst>
             <a:ext uri="{C572A759-6A51-4108-AA02-DFA0A04FC94B}">
-              <ma14:wrappingTextBoxFlag xmlns:ma14="http://schemas.microsoft.com/office/mac/drawingml/2011/main" xmlns="" val="0"/>
+              <ma14:wrappingTextBoxFlag xmlns="" xmlns:ma14="http://schemas.microsoft.com/office/mac/drawingml/2011/main" val="0"/>
             </a:ext>
           </a:extLst>
         </p:spPr>
@@ -13163,7 +13153,7 @@
           </a:prstGeom>
           <a:extLst>
             <a:ext uri="{C572A759-6A51-4108-AA02-DFA0A04FC94B}">
-              <ma14:wrappingTextBoxFlag xmlns:ma14="http://schemas.microsoft.com/office/mac/drawingml/2011/main" xmlns="" val="0"/>
+              <ma14:wrappingTextBoxFlag xmlns="" xmlns:ma14="http://schemas.microsoft.com/office/mac/drawingml/2011/main" val="0"/>
             </a:ext>
           </a:extLst>
         </p:spPr>
@@ -14448,7 +14438,7 @@
           </a:prstGeom>
           <a:extLst>
             <a:ext uri="{C572A759-6A51-4108-AA02-DFA0A04FC94B}">
-              <ma14:wrappingTextBoxFlag xmlns:ma14="http://schemas.microsoft.com/office/mac/drawingml/2011/main" xmlns="" val="0"/>
+              <ma14:wrappingTextBoxFlag xmlns="" xmlns:ma14="http://schemas.microsoft.com/office/mac/drawingml/2011/main" val="0"/>
             </a:ext>
           </a:extLst>
         </p:spPr>
@@ -15031,7 +15021,7 @@
           </a:prstGeom>
           <a:extLst>
             <a:ext uri="{C572A759-6A51-4108-AA02-DFA0A04FC94B}">
-              <ma14:wrappingTextBoxFlag xmlns:ma14="http://schemas.microsoft.com/office/mac/drawingml/2011/main" xmlns="" val="0"/>
+              <ma14:wrappingTextBoxFlag xmlns="" xmlns:ma14="http://schemas.microsoft.com/office/mac/drawingml/2011/main" val="0"/>
             </a:ext>
           </a:extLst>
         </p:spPr>
@@ -15873,7 +15863,7 @@
           </a:prstGeom>
           <a:extLst>
             <a:ext uri="{C572A759-6A51-4108-AA02-DFA0A04FC94B}">
-              <ma14:wrappingTextBoxFlag xmlns:ma14="http://schemas.microsoft.com/office/mac/drawingml/2011/main" xmlns="" val="0"/>
+              <ma14:wrappingTextBoxFlag xmlns="" xmlns:ma14="http://schemas.microsoft.com/office/mac/drawingml/2011/main" val="0"/>
             </a:ext>
           </a:extLst>
         </p:spPr>
@@ -16340,7 +16330,7 @@
           </a:prstGeom>
           <a:extLst>
             <a:ext uri="{C572A759-6A51-4108-AA02-DFA0A04FC94B}">
-              <ma14:wrappingTextBoxFlag xmlns:ma14="http://schemas.microsoft.com/office/mac/drawingml/2011/main" xmlns="" val="0"/>
+              <ma14:wrappingTextBoxFlag xmlns="" xmlns:ma14="http://schemas.microsoft.com/office/mac/drawingml/2011/main" val="0"/>
             </a:ext>
           </a:extLst>
         </p:spPr>
@@ -16671,7 +16661,7 @@
           </a:prstGeom>
           <a:extLst>
             <a:ext uri="{C572A759-6A51-4108-AA02-DFA0A04FC94B}">
-              <ma14:wrappingTextBoxFlag xmlns:ma14="http://schemas.microsoft.com/office/mac/drawingml/2011/main" xmlns="" val="0"/>
+              <ma14:wrappingTextBoxFlag xmlns="" xmlns:ma14="http://schemas.microsoft.com/office/mac/drawingml/2011/main" val="0"/>
             </a:ext>
           </a:extLst>
         </p:spPr>
@@ -18779,7 +18769,7 @@
           </a:prstGeom>
           <a:extLst>
             <a:ext uri="{C572A759-6A51-4108-AA02-DFA0A04FC94B}">
-              <ma14:wrappingTextBoxFlag xmlns:ma14="http://schemas.microsoft.com/office/mac/drawingml/2011/main" xmlns="" val="0"/>
+              <ma14:wrappingTextBoxFlag xmlns="" xmlns:ma14="http://schemas.microsoft.com/office/mac/drawingml/2011/main" val="0"/>
             </a:ext>
           </a:extLst>
         </p:spPr>
@@ -19034,7 +19024,7 @@
           </a:prstGeom>
           <a:extLst>
             <a:ext uri="{C572A759-6A51-4108-AA02-DFA0A04FC94B}">
-              <ma14:wrappingTextBoxFlag xmlns:ma14="http://schemas.microsoft.com/office/mac/drawingml/2011/main" xmlns="" val="0"/>
+              <ma14:wrappingTextBoxFlag xmlns="" xmlns:ma14="http://schemas.microsoft.com/office/mac/drawingml/2011/main" val="0"/>
             </a:ext>
           </a:extLst>
         </p:spPr>
@@ -19560,7 +19550,7 @@
           </a:prstGeom>
           <a:extLst>
             <a:ext uri="{C572A759-6A51-4108-AA02-DFA0A04FC94B}">
-              <ma14:wrappingTextBoxFlag xmlns:ma14="http://schemas.microsoft.com/office/mac/drawingml/2011/main" xmlns="" val="0"/>
+              <ma14:wrappingTextBoxFlag xmlns="" xmlns:ma14="http://schemas.microsoft.com/office/mac/drawingml/2011/main" val="0"/>
             </a:ext>
           </a:extLst>
         </p:spPr>
@@ -20056,7 +20046,7 @@
           </a:prstGeom>
           <a:extLst>
             <a:ext uri="{C572A759-6A51-4108-AA02-DFA0A04FC94B}">
-              <ma14:wrappingTextBoxFlag xmlns:ma14="http://schemas.microsoft.com/office/mac/drawingml/2011/main" xmlns="" val="0"/>
+              <ma14:wrappingTextBoxFlag xmlns="" xmlns:ma14="http://schemas.microsoft.com/office/mac/drawingml/2011/main" val="0"/>
             </a:ext>
           </a:extLst>
         </p:spPr>
@@ -20934,7 +20924,7 @@
           </a:prstGeom>
           <a:extLst>
             <a:ext uri="{C572A759-6A51-4108-AA02-DFA0A04FC94B}">
-              <ma14:wrappingTextBoxFlag xmlns:ma14="http://schemas.microsoft.com/office/mac/drawingml/2011/main" xmlns="" val="0"/>
+              <ma14:wrappingTextBoxFlag xmlns="" xmlns:ma14="http://schemas.microsoft.com/office/mac/drawingml/2011/main" val="0"/>
             </a:ext>
           </a:extLst>
         </p:spPr>
@@ -21865,7 +21855,7 @@
           </a:prstGeom>
           <a:extLst>
             <a:ext uri="{C572A759-6A51-4108-AA02-DFA0A04FC94B}">
-              <ma14:wrappingTextBoxFlag xmlns:ma14="http://schemas.microsoft.com/office/mac/drawingml/2011/main" xmlns="" val="0"/>
+              <ma14:wrappingTextBoxFlag xmlns="" xmlns:ma14="http://schemas.microsoft.com/office/mac/drawingml/2011/main" val="0"/>
             </a:ext>
           </a:extLst>
         </p:spPr>
@@ -22403,7 +22393,7 @@
           </a:prstGeom>
           <a:extLst>
             <a:ext uri="{C572A759-6A51-4108-AA02-DFA0A04FC94B}">
-              <ma14:wrappingTextBoxFlag xmlns:ma14="http://schemas.microsoft.com/office/mac/drawingml/2011/main" xmlns="" val="0"/>
+              <ma14:wrappingTextBoxFlag xmlns="" xmlns:ma14="http://schemas.microsoft.com/office/mac/drawingml/2011/main" val="0"/>
             </a:ext>
           </a:extLst>
         </p:spPr>
@@ -23930,7 +23920,7 @@
           </a:prstGeom>
           <a:extLst>
             <a:ext uri="{C572A759-6A51-4108-AA02-DFA0A04FC94B}">
-              <ma14:wrappingTextBoxFlag xmlns:ma14="http://schemas.microsoft.com/office/mac/drawingml/2011/main" xmlns="" val="0"/>
+              <ma14:wrappingTextBoxFlag xmlns="" xmlns:ma14="http://schemas.microsoft.com/office/mac/drawingml/2011/main" val="0"/>
             </a:ext>
           </a:extLst>
         </p:spPr>
@@ -24291,7 +24281,7 @@
           </a:prstGeom>
           <a:extLst>
             <a:ext uri="{C572A759-6A51-4108-AA02-DFA0A04FC94B}">
-              <ma14:wrappingTextBoxFlag xmlns:ma14="http://schemas.microsoft.com/office/mac/drawingml/2011/main" xmlns="" val="0"/>
+              <ma14:wrappingTextBoxFlag xmlns="" xmlns:ma14="http://schemas.microsoft.com/office/mac/drawingml/2011/main" val="0"/>
             </a:ext>
           </a:extLst>
         </p:spPr>
@@ -24721,7 +24711,7 @@
           </a:prstGeom>
           <a:extLst>
             <a:ext uri="{C572A759-6A51-4108-AA02-DFA0A04FC94B}">
-              <ma14:wrappingTextBoxFlag xmlns:ma14="http://schemas.microsoft.com/office/mac/drawingml/2011/main" xmlns="" val="0"/>
+              <ma14:wrappingTextBoxFlag xmlns="" xmlns:ma14="http://schemas.microsoft.com/office/mac/drawingml/2011/main" val="0"/>
             </a:ext>
           </a:extLst>
         </p:spPr>
@@ -24957,7 +24947,7 @@
           </a:prstGeom>
           <a:extLst>
             <a:ext uri="{C572A759-6A51-4108-AA02-DFA0A04FC94B}">
-              <ma14:wrappingTextBoxFlag xmlns:ma14="http://schemas.microsoft.com/office/mac/drawingml/2011/main" xmlns="" val="0"/>
+              <ma14:wrappingTextBoxFlag xmlns="" xmlns:ma14="http://schemas.microsoft.com/office/mac/drawingml/2011/main" val="0"/>
             </a:ext>
           </a:extLst>
         </p:spPr>
@@ -25193,7 +25183,7 @@
           </a:prstGeom>
           <a:extLst>
             <a:ext uri="{C572A759-6A51-4108-AA02-DFA0A04FC94B}">
-              <ma14:wrappingTextBoxFlag xmlns:ma14="http://schemas.microsoft.com/office/mac/drawingml/2011/main" xmlns="" val="0"/>
+              <ma14:wrappingTextBoxFlag xmlns="" xmlns:ma14="http://schemas.microsoft.com/office/mac/drawingml/2011/main" val="0"/>
             </a:ext>
           </a:extLst>
         </p:spPr>
@@ -26038,7 +26028,7 @@
           </a:prstGeom>
           <a:extLst>
             <a:ext uri="{C572A759-6A51-4108-AA02-DFA0A04FC94B}">
-              <ma14:wrappingTextBoxFlag xmlns:ma14="http://schemas.microsoft.com/office/mac/drawingml/2011/main" xmlns="" val="0"/>
+              <ma14:wrappingTextBoxFlag xmlns="" xmlns:ma14="http://schemas.microsoft.com/office/mac/drawingml/2011/main" val="0"/>
             </a:ext>
           </a:extLst>
         </p:spPr>
@@ -26468,7 +26458,7 @@
           </a:prstGeom>
           <a:extLst>
             <a:ext uri="{C572A759-6A51-4108-AA02-DFA0A04FC94B}">
-              <ma14:wrappingTextBoxFlag xmlns:ma14="http://schemas.microsoft.com/office/mac/drawingml/2011/main" xmlns="" val="0"/>
+              <ma14:wrappingTextBoxFlag xmlns="" xmlns:ma14="http://schemas.microsoft.com/office/mac/drawingml/2011/main" val="0"/>
             </a:ext>
           </a:extLst>
         </p:spPr>
@@ -26876,7 +26866,7 @@
           </a:prstGeom>
           <a:extLst>
             <a:ext uri="{C572A759-6A51-4108-AA02-DFA0A04FC94B}">
-              <ma14:wrappingTextBoxFlag xmlns:ma14="http://schemas.microsoft.com/office/mac/drawingml/2011/main" xmlns="" val="0"/>
+              <ma14:wrappingTextBoxFlag xmlns="" xmlns:ma14="http://schemas.microsoft.com/office/mac/drawingml/2011/main" val="0"/>
             </a:ext>
           </a:extLst>
         </p:spPr>
@@ -28022,7 +28012,7 @@
           </a:prstGeom>
           <a:extLst>
             <a:ext uri="{C572A759-6A51-4108-AA02-DFA0A04FC94B}">
-              <ma14:wrappingTextBoxFlag xmlns:ma14="http://schemas.microsoft.com/office/mac/drawingml/2011/main" xmlns="" val="0"/>
+              <ma14:wrappingTextBoxFlag xmlns="" xmlns:ma14="http://schemas.microsoft.com/office/mac/drawingml/2011/main" val="0"/>
             </a:ext>
           </a:extLst>
         </p:spPr>
@@ -28500,7 +28490,7 @@
           </a:prstGeom>
           <a:extLst>
             <a:ext uri="{C572A759-6A51-4108-AA02-DFA0A04FC94B}">
-              <ma14:wrappingTextBoxFlag xmlns:ma14="http://schemas.microsoft.com/office/mac/drawingml/2011/main" xmlns="" val="0"/>
+              <ma14:wrappingTextBoxFlag xmlns="" xmlns:ma14="http://schemas.microsoft.com/office/mac/drawingml/2011/main" val="0"/>
             </a:ext>
           </a:extLst>
         </p:spPr>
@@ -28736,7 +28726,7 @@
           </a:prstGeom>
           <a:extLst>
             <a:ext uri="{C572A759-6A51-4108-AA02-DFA0A04FC94B}">
-              <ma14:wrappingTextBoxFlag xmlns:ma14="http://schemas.microsoft.com/office/mac/drawingml/2011/main" xmlns="" val="0"/>
+              <ma14:wrappingTextBoxFlag xmlns="" xmlns:ma14="http://schemas.microsoft.com/office/mac/drawingml/2011/main" val="0"/>
             </a:ext>
           </a:extLst>
         </p:spPr>
@@ -29072,7 +29062,7 @@
           </a:prstGeom>
           <a:extLst>
             <a:ext uri="{C572A759-6A51-4108-AA02-DFA0A04FC94B}">
-              <ma14:wrappingTextBoxFlag xmlns:ma14="http://schemas.microsoft.com/office/mac/drawingml/2011/main" xmlns="" val="0"/>
+              <ma14:wrappingTextBoxFlag xmlns="" xmlns:ma14="http://schemas.microsoft.com/office/mac/drawingml/2011/main" val="0"/>
             </a:ext>
           </a:extLst>
         </p:spPr>
@@ -29871,7 +29861,7 @@
           </a:prstGeom>
           <a:extLst>
             <a:ext uri="{C572A759-6A51-4108-AA02-DFA0A04FC94B}">
-              <ma14:wrappingTextBoxFlag xmlns:ma14="http://schemas.microsoft.com/office/mac/drawingml/2011/main" xmlns="" val="0"/>
+              <ma14:wrappingTextBoxFlag xmlns="" xmlns:ma14="http://schemas.microsoft.com/office/mac/drawingml/2011/main" val="0"/>
             </a:ext>
           </a:extLst>
         </p:spPr>
@@ -30224,7 +30214,7 @@
           </a:prstGeom>
           <a:extLst>
             <a:ext uri="{C572A759-6A51-4108-AA02-DFA0A04FC94B}">
-              <ma14:wrappingTextBoxFlag xmlns:ma14="http://schemas.microsoft.com/office/mac/drawingml/2011/main" xmlns="" val="0"/>
+              <ma14:wrappingTextBoxFlag xmlns="" xmlns:ma14="http://schemas.microsoft.com/office/mac/drawingml/2011/main" val="0"/>
             </a:ext>
           </a:extLst>
         </p:spPr>
@@ -31368,7 +31358,7 @@
           </a:prstGeom>
           <a:extLst>
             <a:ext uri="{C572A759-6A51-4108-AA02-DFA0A04FC94B}">
-              <ma14:wrappingTextBoxFlag xmlns:ma14="http://schemas.microsoft.com/office/mac/drawingml/2011/main" xmlns="" val="0"/>
+              <ma14:wrappingTextBoxFlag xmlns="" xmlns:ma14="http://schemas.microsoft.com/office/mac/drawingml/2011/main" val="0"/>
             </a:ext>
           </a:extLst>
         </p:spPr>
@@ -32514,7 +32504,7 @@
           </a:prstGeom>
           <a:extLst>
             <a:ext uri="{C572A759-6A51-4108-AA02-DFA0A04FC94B}">
-              <ma14:wrappingTextBoxFlag xmlns:ma14="http://schemas.microsoft.com/office/mac/drawingml/2011/main" xmlns="" val="0"/>
+              <ma14:wrappingTextBoxFlag xmlns="" xmlns:ma14="http://schemas.microsoft.com/office/mac/drawingml/2011/main" val="0"/>
             </a:ext>
           </a:extLst>
         </p:spPr>
@@ -33579,7 +33569,7 @@
           </a:prstGeom>
           <a:extLst>
             <a:ext uri="{C572A759-6A51-4108-AA02-DFA0A04FC94B}">
-              <ma14:wrappingTextBoxFlag xmlns:ma14="http://schemas.microsoft.com/office/mac/drawingml/2011/main" xmlns="" val="0"/>
+              <ma14:wrappingTextBoxFlag xmlns="" xmlns:ma14="http://schemas.microsoft.com/office/mac/drawingml/2011/main" val="0"/>
             </a:ext>
           </a:extLst>
         </p:spPr>
@@ -34973,7 +34963,7 @@
           </a:prstGeom>
           <a:extLst>
             <a:ext uri="{C572A759-6A51-4108-AA02-DFA0A04FC94B}">
-              <ma14:wrappingTextBoxFlag xmlns:ma14="http://schemas.microsoft.com/office/mac/drawingml/2011/main" xmlns="" val="0"/>
+              <ma14:wrappingTextBoxFlag xmlns="" xmlns:ma14="http://schemas.microsoft.com/office/mac/drawingml/2011/main" val="0"/>
             </a:ext>
           </a:extLst>
         </p:spPr>
@@ -35209,7 +35199,7 @@
           </a:prstGeom>
           <a:extLst>
             <a:ext uri="{C572A759-6A51-4108-AA02-DFA0A04FC94B}">
-              <ma14:wrappingTextBoxFlag xmlns:ma14="http://schemas.microsoft.com/office/mac/drawingml/2011/main" xmlns="" val="0"/>
+              <ma14:wrappingTextBoxFlag xmlns="" xmlns:ma14="http://schemas.microsoft.com/office/mac/drawingml/2011/main" val="0"/>
             </a:ext>
           </a:extLst>
         </p:spPr>
@@ -35521,7 +35511,7 @@
           </a:prstGeom>
           <a:extLst>
             <a:ext uri="{C572A759-6A51-4108-AA02-DFA0A04FC94B}">
-              <ma14:wrappingTextBoxFlag xmlns:ma14="http://schemas.microsoft.com/office/mac/drawingml/2011/main" xmlns="" val="0"/>
+              <ma14:wrappingTextBoxFlag xmlns="" xmlns:ma14="http://schemas.microsoft.com/office/mac/drawingml/2011/main" val="0"/>
             </a:ext>
           </a:extLst>
         </p:spPr>
@@ -36628,7 +36618,7 @@
           </a:prstGeom>
           <a:extLst>
             <a:ext uri="{C572A759-6A51-4108-AA02-DFA0A04FC94B}">
-              <ma14:wrappingTextBoxFlag xmlns:ma14="http://schemas.microsoft.com/office/mac/drawingml/2011/main" xmlns="" val="0"/>
+              <ma14:wrappingTextBoxFlag xmlns="" xmlns:ma14="http://schemas.microsoft.com/office/mac/drawingml/2011/main" val="0"/>
             </a:ext>
           </a:extLst>
         </p:spPr>
@@ -36988,7 +36978,7 @@
           </a:prstGeom>
           <a:extLst>
             <a:ext uri="{C572A759-6A51-4108-AA02-DFA0A04FC94B}">
-              <ma14:wrappingTextBoxFlag xmlns:ma14="http://schemas.microsoft.com/office/mac/drawingml/2011/main" xmlns="" val="0"/>
+              <ma14:wrappingTextBoxFlag xmlns="" xmlns:ma14="http://schemas.microsoft.com/office/mac/drawingml/2011/main" val="0"/>
             </a:ext>
           </a:extLst>
         </p:spPr>
@@ -37224,7 +37214,7 @@
           </a:prstGeom>
           <a:extLst>
             <a:ext uri="{C572A759-6A51-4108-AA02-DFA0A04FC94B}">
-              <ma14:wrappingTextBoxFlag xmlns:ma14="http://schemas.microsoft.com/office/mac/drawingml/2011/main" xmlns="" val="0"/>
+              <ma14:wrappingTextBoxFlag xmlns="" xmlns:ma14="http://schemas.microsoft.com/office/mac/drawingml/2011/main" val="0"/>
             </a:ext>
           </a:extLst>
         </p:spPr>
@@ -37654,7 +37644,7 @@
           </a:prstGeom>
           <a:extLst>
             <a:ext uri="{C572A759-6A51-4108-AA02-DFA0A04FC94B}">
-              <ma14:wrappingTextBoxFlag xmlns:ma14="http://schemas.microsoft.com/office/mac/drawingml/2011/main" xmlns="" val="0"/>
+              <ma14:wrappingTextBoxFlag xmlns="" xmlns:ma14="http://schemas.microsoft.com/office/mac/drawingml/2011/main" val="0"/>
             </a:ext>
           </a:extLst>
         </p:spPr>
@@ -38326,7 +38316,7 @@
           </a:prstGeom>
           <a:extLst>
             <a:ext uri="{C572A759-6A51-4108-AA02-DFA0A04FC94B}">
-              <ma14:wrappingTextBoxFlag xmlns:ma14="http://schemas.microsoft.com/office/mac/drawingml/2011/main" xmlns="" val="0"/>
+              <ma14:wrappingTextBoxFlag xmlns="" xmlns:ma14="http://schemas.microsoft.com/office/mac/drawingml/2011/main" val="0"/>
             </a:ext>
           </a:extLst>
         </p:spPr>
@@ -38790,7 +38780,7 @@
           </a:prstGeom>
           <a:extLst>
             <a:ext uri="{C572A759-6A51-4108-AA02-DFA0A04FC94B}">
-              <ma14:wrappingTextBoxFlag xmlns:ma14="http://schemas.microsoft.com/office/mac/drawingml/2011/main" xmlns="" val="0"/>
+              <ma14:wrappingTextBoxFlag xmlns="" xmlns:ma14="http://schemas.microsoft.com/office/mac/drawingml/2011/main" val="0"/>
             </a:ext>
           </a:extLst>
         </p:spPr>
@@ -39796,7 +39786,7 @@
           </a:prstGeom>
           <a:extLst>
             <a:ext uri="{C572A759-6A51-4108-AA02-DFA0A04FC94B}">
-              <ma14:wrappingTextBoxFlag xmlns:ma14="http://schemas.microsoft.com/office/mac/drawingml/2011/main" xmlns="" val="0"/>
+              <ma14:wrappingTextBoxFlag xmlns="" xmlns:ma14="http://schemas.microsoft.com/office/mac/drawingml/2011/main" val="0"/>
             </a:ext>
           </a:extLst>
         </p:spPr>
@@ -40644,7 +40634,7 @@
           </a:prstGeom>
           <a:extLst>
             <a:ext uri="{C572A759-6A51-4108-AA02-DFA0A04FC94B}">
-              <ma14:wrappingTextBoxFlag xmlns:ma14="http://schemas.microsoft.com/office/mac/drawingml/2011/main" xmlns="" val="0"/>
+              <ma14:wrappingTextBoxFlag xmlns="" xmlns:ma14="http://schemas.microsoft.com/office/mac/drawingml/2011/main" val="0"/>
             </a:ext>
           </a:extLst>
         </p:spPr>
@@ -41084,7 +41074,7 @@
           </a:prstGeom>
           <a:extLst>
             <a:ext uri="{C572A759-6A51-4108-AA02-DFA0A04FC94B}">
-              <ma14:wrappingTextBoxFlag xmlns:ma14="http://schemas.microsoft.com/office/mac/drawingml/2011/main" xmlns="" val="0"/>
+              <ma14:wrappingTextBoxFlag xmlns="" xmlns:ma14="http://schemas.microsoft.com/office/mac/drawingml/2011/main" val="0"/>
             </a:ext>
           </a:extLst>
         </p:spPr>
@@ -41493,7 +41483,7 @@
           </a:prstGeom>
           <a:extLst>
             <a:ext uri="{C572A759-6A51-4108-AA02-DFA0A04FC94B}">
-              <ma14:wrappingTextBoxFlag xmlns:ma14="http://schemas.microsoft.com/office/mac/drawingml/2011/main" xmlns="" val="0"/>
+              <ma14:wrappingTextBoxFlag xmlns="" xmlns:ma14="http://schemas.microsoft.com/office/mac/drawingml/2011/main" val="0"/>
             </a:ext>
           </a:extLst>
         </p:spPr>
@@ -42345,7 +42335,7 @@
           </a:prstGeom>
           <a:extLst>
             <a:ext uri="{C572A759-6A51-4108-AA02-DFA0A04FC94B}">
-              <ma14:wrappingTextBoxFlag xmlns:ma14="http://schemas.microsoft.com/office/mac/drawingml/2011/main" xmlns="" val="0"/>
+              <ma14:wrappingTextBoxFlag xmlns="" xmlns:ma14="http://schemas.microsoft.com/office/mac/drawingml/2011/main" val="0"/>
             </a:ext>
           </a:extLst>
         </p:spPr>
@@ -42581,7 +42571,7 @@
           </a:prstGeom>
           <a:extLst>
             <a:ext uri="{C572A759-6A51-4108-AA02-DFA0A04FC94B}">
-              <ma14:wrappingTextBoxFlag xmlns:ma14="http://schemas.microsoft.com/office/mac/drawingml/2011/main" xmlns="" val="0"/>
+              <ma14:wrappingTextBoxFlag xmlns="" xmlns:ma14="http://schemas.microsoft.com/office/mac/drawingml/2011/main" val="0"/>
             </a:ext>
           </a:extLst>
         </p:spPr>
@@ -43019,7 +43009,7 @@
           </a:prstGeom>
           <a:extLst>
             <a:ext uri="{C572A759-6A51-4108-AA02-DFA0A04FC94B}">
-              <ma14:wrappingTextBoxFlag xmlns:ma14="http://schemas.microsoft.com/office/mac/drawingml/2011/main" xmlns="" val="0"/>
+              <ma14:wrappingTextBoxFlag xmlns="" xmlns:ma14="http://schemas.microsoft.com/office/mac/drawingml/2011/main" val="0"/>
             </a:ext>
           </a:extLst>
         </p:spPr>
@@ -43526,7 +43516,7 @@
           </a:prstGeom>
           <a:extLst>
             <a:ext uri="{C572A759-6A51-4108-AA02-DFA0A04FC94B}">
-              <ma14:wrappingTextBoxFlag xmlns:ma14="http://schemas.microsoft.com/office/mac/drawingml/2011/main" xmlns="" val="0"/>
+              <ma14:wrappingTextBoxFlag xmlns="" xmlns:ma14="http://schemas.microsoft.com/office/mac/drawingml/2011/main" val="0"/>
             </a:ext>
           </a:extLst>
         </p:spPr>
@@ -44333,7 +44323,7 @@
           </a:prstGeom>
           <a:extLst>
             <a:ext uri="{C572A759-6A51-4108-AA02-DFA0A04FC94B}">
-              <ma14:wrappingTextBoxFlag xmlns:ma14="http://schemas.microsoft.com/office/mac/drawingml/2011/main" xmlns="" val="0"/>
+              <ma14:wrappingTextBoxFlag xmlns="" xmlns:ma14="http://schemas.microsoft.com/office/mac/drawingml/2011/main" val="0"/>
             </a:ext>
           </a:extLst>
         </p:spPr>
@@ -45450,7 +45440,7 @@
           </a:prstGeom>
           <a:extLst>
             <a:ext uri="{C572A759-6A51-4108-AA02-DFA0A04FC94B}">
-              <ma14:wrappingTextBoxFlag xmlns:ma14="http://schemas.microsoft.com/office/mac/drawingml/2011/main" xmlns="" val="0"/>
+              <ma14:wrappingTextBoxFlag xmlns="" xmlns:ma14="http://schemas.microsoft.com/office/mac/drawingml/2011/main" val="0"/>
             </a:ext>
           </a:extLst>
         </p:spPr>
@@ -46031,7 +46021,7 @@
           </a:prstGeom>
           <a:extLst>
             <a:ext uri="{C572A759-6A51-4108-AA02-DFA0A04FC94B}">
-              <ma14:wrappingTextBoxFlag xmlns:ma14="http://schemas.microsoft.com/office/mac/drawingml/2011/main" xmlns="" val="0"/>
+              <ma14:wrappingTextBoxFlag xmlns="" xmlns:ma14="http://schemas.microsoft.com/office/mac/drawingml/2011/main" val="0"/>
             </a:ext>
           </a:extLst>
         </p:spPr>
@@ -46928,7 +46918,7 @@
           </a:prstGeom>
           <a:extLst>
             <a:ext uri="{C572A759-6A51-4108-AA02-DFA0A04FC94B}">
-              <ma14:wrappingTextBoxFlag xmlns:ma14="http://schemas.microsoft.com/office/mac/drawingml/2011/main" xmlns="" val="0"/>
+              <ma14:wrappingTextBoxFlag xmlns="" xmlns:ma14="http://schemas.microsoft.com/office/mac/drawingml/2011/main" val="0"/>
             </a:ext>
           </a:extLst>
         </p:spPr>
@@ -47164,7 +47154,7 @@
           </a:prstGeom>
           <a:extLst>
             <a:ext uri="{C572A759-6A51-4108-AA02-DFA0A04FC94B}">
-              <ma14:wrappingTextBoxFlag xmlns:ma14="http://schemas.microsoft.com/office/mac/drawingml/2011/main" xmlns="" val="0"/>
+              <ma14:wrappingTextBoxFlag xmlns="" xmlns:ma14="http://schemas.microsoft.com/office/mac/drawingml/2011/main" val="0"/>
             </a:ext>
           </a:extLst>
         </p:spPr>
@@ -47571,7 +47561,7 @@
           </a:prstGeom>
           <a:extLst>
             <a:ext uri="{C572A759-6A51-4108-AA02-DFA0A04FC94B}">
-              <ma14:wrappingTextBoxFlag xmlns:ma14="http://schemas.microsoft.com/office/mac/drawingml/2011/main" xmlns="" val="0"/>
+              <ma14:wrappingTextBoxFlag xmlns="" xmlns:ma14="http://schemas.microsoft.com/office/mac/drawingml/2011/main" val="0"/>
             </a:ext>
           </a:extLst>
         </p:spPr>
@@ -47888,7 +47878,7 @@
           </a:prstGeom>
           <a:extLst>
             <a:ext uri="{C572A759-6A51-4108-AA02-DFA0A04FC94B}">
-              <ma14:wrappingTextBoxFlag xmlns:ma14="http://schemas.microsoft.com/office/mac/drawingml/2011/main" xmlns="" val="0"/>
+              <ma14:wrappingTextBoxFlag xmlns="" xmlns:ma14="http://schemas.microsoft.com/office/mac/drawingml/2011/main" val="0"/>
             </a:ext>
           </a:extLst>
         </p:spPr>
@@ -48185,7 +48175,7 @@
           </a:prstGeom>
           <a:extLst>
             <a:ext uri="{C572A759-6A51-4108-AA02-DFA0A04FC94B}">
-              <ma14:wrappingTextBoxFlag xmlns:ma14="http://schemas.microsoft.com/office/mac/drawingml/2011/main" xmlns="" val="0"/>
+              <ma14:wrappingTextBoxFlag xmlns="" xmlns:ma14="http://schemas.microsoft.com/office/mac/drawingml/2011/main" val="0"/>
             </a:ext>
           </a:extLst>
         </p:spPr>
@@ -48486,7 +48476,7 @@
           </a:prstGeom>
           <a:extLst>
             <a:ext uri="{C572A759-6A51-4108-AA02-DFA0A04FC94B}">
-              <ma14:wrappingTextBoxFlag xmlns:ma14="http://schemas.microsoft.com/office/mac/drawingml/2011/main" xmlns="" val="0"/>
+              <ma14:wrappingTextBoxFlag xmlns="" xmlns:ma14="http://schemas.microsoft.com/office/mac/drawingml/2011/main" val="0"/>
             </a:ext>
           </a:extLst>
         </p:spPr>
@@ -48722,7 +48712,7 @@
           </a:prstGeom>
           <a:extLst>
             <a:ext uri="{C572A759-6A51-4108-AA02-DFA0A04FC94B}">
-              <ma14:wrappingTextBoxFlag xmlns:ma14="http://schemas.microsoft.com/office/mac/drawingml/2011/main" xmlns="" val="0"/>
+              <ma14:wrappingTextBoxFlag xmlns="" xmlns:ma14="http://schemas.microsoft.com/office/mac/drawingml/2011/main" val="0"/>
             </a:ext>
           </a:extLst>
         </p:spPr>
@@ -49015,7 +49005,7 @@
           </a:prstGeom>
           <a:extLst>
             <a:ext uri="{C572A759-6A51-4108-AA02-DFA0A04FC94B}">
-              <ma14:wrappingTextBoxFlag xmlns:ma14="http://schemas.microsoft.com/office/mac/drawingml/2011/main" xmlns="" val="0"/>
+              <ma14:wrappingTextBoxFlag xmlns="" xmlns:ma14="http://schemas.microsoft.com/office/mac/drawingml/2011/main" val="0"/>
             </a:ext>
           </a:extLst>
         </p:spPr>
@@ -49987,7 +49977,7 @@
           </a:prstGeom>
           <a:extLst>
             <a:ext uri="{C572A759-6A51-4108-AA02-DFA0A04FC94B}">
-              <ma14:wrappingTextBoxFlag xmlns:ma14="http://schemas.microsoft.com/office/mac/drawingml/2011/main" xmlns="" val="0"/>
+              <ma14:wrappingTextBoxFlag xmlns="" xmlns:ma14="http://schemas.microsoft.com/office/mac/drawingml/2011/main" val="0"/>
             </a:ext>
           </a:extLst>
         </p:spPr>

</xml_diff>